<commit_message>
Implement local pptx-official skill, add Capability Classifications slide to HTML and PPTX decks
</commit_message>
<xml_diff>
--- a/docs/cucp/cucp_presentation.pptx
+++ b/docs/cucp/cucp_presentation.pptx
@@ -11,6 +11,7 @@
     <p:sldId id="259" r:id="rId10"/>
     <p:sldId id="260" r:id="rId11"/>
     <p:sldId id="261" r:id="rId12"/>
+    <p:sldId id="262" r:id="rId13"/>
   </p:sldIdLst>
   <p:sldSz cx="12191695" cy="6858000" type="screen4x3"/>
   <p:notesSz cx="6858000" cy="9144000"/>
@@ -3132,7 +3133,7 @@
               </a:defRPr>
             </a:pPr>
             <a:r>
-              <a:t>COUPA · SR. LEAD, P&amp;T OPERATIONS · 90-DAY PLAN</a:t>
+              <a:t>COUPA · SR. LEAD, P&amp;T OPERATIONS · 90-DAY ROLLOUT</a:t>
             </a:r>
           </a:p>
         </p:txBody>
@@ -3511,7 +3512,7 @@
               </a:defRPr>
             </a:pPr>
             <a:r>
-              <a:t>The Challenge — and the Reframe</a:t>
+              <a:t>Change Management &amp; Adoption Strategy</a:t>
             </a:r>
           </a:p>
         </p:txBody>
@@ -3993,7 +3994,7 @@
               </a:defRPr>
             </a:pPr>
             <a:r>
-              <a:t>90-Day Rollout: Pilot → Learn → Scale</a:t>
+              <a:t>Capability Classifications: Standard vs. AI</a:t>
             </a:r>
           </a:p>
         </p:txBody>
@@ -4029,7 +4030,7 @@
               </a:defRPr>
             </a:pPr>
             <a:r>
-              <a:t>No big-bang mandate. Build trust through service, then scale on proven evidence.</a:t>
+              <a:t>Pre-GA validation strategies are structured to match the risk profile of each release path.</a:t>
             </a:r>
           </a:p>
         </p:txBody>
@@ -4043,7 +4044,7 @@
         <p:spPr>
           <a:xfrm>
             <a:off x="731520" y="1645920"/>
-            <a:ext cx="3383280" cy="4389120"/>
+            <a:ext cx="5212080" cy="2926080"/>
           </a:xfrm>
           <a:prstGeom prst="roundRect">
             <a:avLst/>
@@ -4051,9 +4052,9 @@
           <a:solidFill>
             <a:srgbClr val="FFFFFF"/>
           </a:solidFill>
-          <a:ln w="25400">
+          <a:ln w="19050">
             <a:solidFill>
-              <a:srgbClr val="FFAB00"/>
+              <a:srgbClr val="0052CC"/>
             </a:solidFill>
           </a:ln>
         </p:spPr>
@@ -4087,8 +4088,8 @@
         </p:nvSpPr>
         <p:spPr>
           <a:xfrm>
-            <a:off x="868680" y="1737360"/>
-            <a:ext cx="3108960" cy="4206240"/>
+            <a:off x="914400" y="1737360"/>
+            <a:ext cx="4846320" cy="2651760"/>
           </a:xfrm>
           <a:prstGeom prst="rect">
             <a:avLst/>
@@ -4102,20 +4103,23 @@
           <a:lstStyle/>
           <a:p>
             <a:pPr>
-              <a:defRPr sz="1100" b="1">
-                <a:solidFill>
-                  <a:srgbClr val="FFAB00"/>
-                </a:solidFill>
-                <a:latin typeface="Segoe UI"/>
-              </a:defRPr>
-            </a:pPr>
-            <a:r>
-              <a:t>PHASE 1</a:t>
-            </a:r>
-          </a:p>
-          <a:p>
-            <a:pPr>
-              <a:defRPr sz="1800" b="1">
+              <a:defRPr sz="1200" b="1">
+                <a:solidFill>
+                  <a:srgbClr val="0052CC"/>
+                </a:solidFill>
+                <a:latin typeface="Segoe UI"/>
+              </a:defRPr>
+            </a:pPr>
+            <a:r>
+              <a:t>STANDARD CAPABILITIES</a:t>
+            </a:r>
+          </a:p>
+          <a:p>
+            <a:pPr>
+              <a:spcBef>
+                <a:spcPts val="600"/>
+              </a:spcBef>
+              <a:defRPr sz="1250">
                 <a:solidFill>
                   <a:srgbClr val="172B4D"/>
                 </a:solidFill>
@@ -4123,31 +4127,15 @@
               </a:defRPr>
             </a:pPr>
             <a:r>
-              <a:t>Days 1–30</a:t>
-            </a:r>
-          </a:p>
-          <a:p>
-            <a:pPr>
-              <a:spcAft>
-                <a:spcPts val="800"/>
-              </a:spcAft>
-              <a:defRPr sz="1300" i="1">
-                <a:solidFill>
-                  <a:srgbClr val="5E6C84"/>
-                </a:solidFill>
-                <a:latin typeface="Segoe UI"/>
-              </a:defRPr>
-            </a:pPr>
-            <a:r>
-              <a:t>Listen &amp; Align</a:t>
-            </a:r>
-          </a:p>
-          <a:p>
-            <a:pPr>
-              <a:spcAft>
-                <a:spcPts val="400"/>
-              </a:spcAft>
-              <a:defRPr sz="1200">
+              <a:t>•  Definition: Built on deterministic logic and structured workflows (no AI).</a:t>
+            </a:r>
+          </a:p>
+          <a:p>
+            <a:pPr>
+              <a:spcBef>
+                <a:spcPts val="600"/>
+              </a:spcBef>
+              <a:defRPr sz="1250">
                 <a:solidFill>
                   <a:srgbClr val="172B4D"/>
                 </a:solidFill>
@@ -4155,15 +4143,15 @@
               </a:defRPr>
             </a:pPr>
             <a:r>
-              <a:t>•  1:1 listening sessions (8–10 PMs)</a:t>
-            </a:r>
-          </a:p>
-          <a:p>
-            <a:pPr>
-              <a:spcAft>
-                <a:spcPts val="400"/>
-              </a:spcAft>
-              <a:defRPr sz="1200">
+              <a:t>•  Examples: New sourcing dashboards, workflow routing rules, UI redesigns.</a:t>
+            </a:r>
+          </a:p>
+          <a:p>
+            <a:pPr>
+              <a:spcBef>
+                <a:spcPts val="600"/>
+              </a:spcBef>
+              <a:defRPr sz="1250">
                 <a:solidFill>
                   <a:srgbClr val="172B4D"/>
                 </a:solidFill>
@@ -4171,15 +4159,15 @@
               </a:defRPr>
             </a:pPr>
             <a:r>
-              <a:t>•  Shadow 2 live EAP/LA cycles</a:t>
-            </a:r>
-          </a:p>
-          <a:p>
-            <a:pPr>
-              <a:spcAft>
-                <a:spcPts val="400"/>
-              </a:spcAft>
-              <a:defRPr sz="1200">
+              <a:t>•  Pre-GA Focus: Validate operational readiness, scalability, support enablement.</a:t>
+            </a:r>
+          </a:p>
+          <a:p>
+            <a:pPr>
+              <a:spcBef>
+                <a:spcPts val="600"/>
+              </a:spcBef>
+              <a:defRPr sz="1250">
                 <a:solidFill>
                   <a:srgbClr val="172B4D"/>
                 </a:solidFill>
@@ -4187,39 +4175,7 @@
               </a:defRPr>
             </a:pPr>
             <a:r>
-              <a:t>•  Map informal processes in use</a:t>
-            </a:r>
-          </a:p>
-          <a:p>
-            <a:pPr>
-              <a:spcAft>
-                <a:spcPts val="400"/>
-              </a:spcAft>
-              <a:defRPr sz="1200">
-                <a:solidFill>
-                  <a:srgbClr val="172B4D"/>
-                </a:solidFill>
-                <a:latin typeface="Segoe UI"/>
-              </a:defRPr>
-            </a:pPr>
-            <a:r>
-              <a:t>•  Identify proto-champions</a:t>
-            </a:r>
-          </a:p>
-          <a:p>
-            <a:pPr>
-              <a:spcAft>
-                <a:spcPts val="400"/>
-              </a:spcAft>
-              <a:defRPr sz="1200">
-                <a:solidFill>
-                  <a:srgbClr val="172B4D"/>
-                </a:solidFill>
-                <a:latin typeface="Segoe UI"/>
-              </a:defRPr>
-            </a:pPr>
-            <a:r>
-              <a:t>•  Select pilot: 1 Standard + 1 AI</a:t>
+              <a:t>•  Cohort Sizes: Controlled, small customer cohorts (5-10 max) are sufficient.</a:t>
             </a:r>
           </a:p>
         </p:txBody>
@@ -4232,87 +4188,8 @@
         </p:nvSpPr>
         <p:spPr>
           <a:xfrm>
-            <a:off x="868680" y="5212080"/>
-            <a:ext cx="3108960" cy="640080"/>
-          </a:xfrm>
-          <a:prstGeom prst="roundRect">
-            <a:avLst/>
-          </a:prstGeom>
-          <a:solidFill>
-            <a:srgbClr val="FFF0B5"/>
-          </a:solidFill>
-          <a:ln>
-            <a:noFill/>
-          </a:ln>
-        </p:spPr>
-        <p:style>
-          <a:lnRef idx="1">
-            <a:schemeClr val="accent1"/>
-          </a:lnRef>
-          <a:fillRef idx="3">
-            <a:schemeClr val="accent1"/>
-          </a:fillRef>
-          <a:effectRef idx="2">
-            <a:schemeClr val="accent1"/>
-          </a:effectRef>
-          <a:fontRef idx="minor">
-            <a:schemeClr val="lt1"/>
-          </a:fontRef>
-        </p:style>
-        <p:txBody>
-          <a:bodyPr rtlCol="0" anchor="ctr"/>
-          <a:lstStyle/>
-          <a:p>
-            <a:pPr algn="ctr"/>
-          </a:p>
-        </p:txBody>
-      </p:sp>
-      <p:sp>
-        <p:nvSpPr>
-          <p:cNvPr id="7" name="TextBox 6"/>
-          <p:cNvSpPr txBox="1"/>
-          <p:nvPr/>
-        </p:nvSpPr>
-        <p:spPr>
-          <a:xfrm>
-            <a:off x="868680" y="5212080"/>
-            <a:ext cx="3108960" cy="640080"/>
-          </a:xfrm>
-          <a:prstGeom prst="rect">
-            <a:avLst/>
-          </a:prstGeom>
-          <a:noFill/>
-        </p:spPr>
-        <p:txBody>
-          <a:bodyPr wrap="square">
-            <a:spAutoFit/>
-          </a:bodyPr>
-          <a:lstStyle/>
-          <a:p>
-            <a:pPr algn="ctr">
-              <a:defRPr sz="1100" b="1">
-                <a:solidFill>
-                  <a:srgbClr val="172B4D"/>
-                </a:solidFill>
-                <a:latin typeface="Segoe UI"/>
-              </a:defRPr>
-            </a:pPr>
-            <a:r>
-              <a:t>Friction map + pilot cohort confirmed</a:t>
-            </a:r>
-          </a:p>
-        </p:txBody>
-      </p:sp>
-      <p:sp>
-        <p:nvSpPr>
-          <p:cNvPr id="8" name="Rounded Rectangle 7"/>
-          <p:cNvSpPr/>
-          <p:nvPr/>
-        </p:nvSpPr>
-        <p:spPr>
-          <a:xfrm>
-            <a:off x="4389120" y="1645920"/>
-            <a:ext cx="3383280" cy="4389120"/>
+            <a:off x="6217920" y="1645920"/>
+            <a:ext cx="5212080" cy="2926080"/>
           </a:xfrm>
           <a:prstGeom prst="roundRect">
             <a:avLst/>
@@ -4320,9 +4197,9 @@
           <a:solidFill>
             <a:srgbClr val="FFFFFF"/>
           </a:solidFill>
-          <a:ln w="25400">
+          <a:ln w="19050">
             <a:solidFill>
-              <a:srgbClr val="0052CC"/>
+              <a:srgbClr val="36B37E"/>
             </a:solidFill>
           </a:ln>
         </p:spPr>
@@ -4350,14 +4227,14 @@
       </p:sp>
       <p:sp>
         <p:nvSpPr>
-          <p:cNvPr id="9" name="TextBox 8"/>
+          <p:cNvPr id="7" name="TextBox 6"/>
           <p:cNvSpPr txBox="1"/>
           <p:nvPr/>
         </p:nvSpPr>
         <p:spPr>
           <a:xfrm>
-            <a:off x="4526280" y="1737360"/>
-            <a:ext cx="3108960" cy="4206240"/>
+            <a:off x="6400800" y="1737360"/>
+            <a:ext cx="4846320" cy="2651760"/>
           </a:xfrm>
           <a:prstGeom prst="rect">
             <a:avLst/>
@@ -4371,20 +4248,23 @@
           <a:lstStyle/>
           <a:p>
             <a:pPr>
-              <a:defRPr sz="1100" b="1">
-                <a:solidFill>
-                  <a:srgbClr val="0052CC"/>
-                </a:solidFill>
-                <a:latin typeface="Segoe UI"/>
-              </a:defRPr>
-            </a:pPr>
-            <a:r>
-              <a:t>PHASE 2</a:t>
-            </a:r>
-          </a:p>
-          <a:p>
-            <a:pPr>
-              <a:defRPr sz="1800" b="1">
+              <a:defRPr sz="1200" b="1">
+                <a:solidFill>
+                  <a:srgbClr val="36B37E"/>
+                </a:solidFill>
+                <a:latin typeface="Segoe UI"/>
+              </a:defRPr>
+            </a:pPr>
+            <a:r>
+              <a:t>AI CAPABILITIES (AI-ASSISTED &amp; AGENTIC)</a:t>
+            </a:r>
+          </a:p>
+          <a:p>
+            <a:pPr>
+              <a:spcBef>
+                <a:spcPts val="600"/>
+              </a:spcBef>
+              <a:defRPr sz="1250">
                 <a:solidFill>
                   <a:srgbClr val="172B4D"/>
                 </a:solidFill>
@@ -4392,31 +4272,15 @@
               </a:defRPr>
             </a:pPr>
             <a:r>
-              <a:t>Days 31–60</a:t>
-            </a:r>
-          </a:p>
-          <a:p>
-            <a:pPr>
-              <a:spcAft>
-                <a:spcPts val="800"/>
-              </a:spcAft>
-              <a:defRPr sz="1300" i="1">
-                <a:solidFill>
-                  <a:srgbClr val="5E6C84"/>
-                </a:solidFill>
-                <a:latin typeface="Segoe UI"/>
-              </a:defRPr>
-            </a:pPr>
-            <a:r>
-              <a:t>Pilot &amp; Refine</a:t>
-            </a:r>
-          </a:p>
-          <a:p>
-            <a:pPr>
-              <a:spcAft>
-                <a:spcPts val="400"/>
-              </a:spcAft>
-              <a:defRPr sz="1200">
+              <a:t>•  Definition: Powered by ML/LLMs. Probabilistic models requiring user feedback loop.</a:t>
+            </a:r>
+          </a:p>
+          <a:p>
+            <a:pPr>
+              <a:spcBef>
+                <a:spcPts val="600"/>
+              </a:spcBef>
+              <a:defRPr sz="1250">
                 <a:solidFill>
                   <a:srgbClr val="172B4D"/>
                 </a:solidFill>
@@ -4424,15 +4288,15 @@
               </a:defRPr>
             </a:pPr>
             <a:r>
-              <a:t>•  Run 2–3 live CuCP pilots</a:t>
-            </a:r>
-          </a:p>
-          <a:p>
-            <a:pPr>
-              <a:spcAft>
-                <a:spcPts val="400"/>
-              </a:spcAft>
-              <a:defRPr sz="1200">
+              <a:t>•  Examples: Copilot context recommendations, Agent Studio autonomous workflows.</a:t>
+            </a:r>
+          </a:p>
+          <a:p>
+            <a:pPr>
+              <a:spcBef>
+                <a:spcPts val="600"/>
+              </a:spcBef>
+              <a:defRPr sz="1250">
                 <a:solidFill>
                   <a:srgbClr val="172B4D"/>
                 </a:solidFill>
@@ -4440,15 +4304,15 @@
               </a:defRPr>
             </a:pPr>
             <a:r>
-              <a:t>•  I act as embedded CuCP Concierge</a:t>
-            </a:r>
-          </a:p>
-          <a:p>
-            <a:pPr>
-              <a:spcAft>
-                <a:spcPts val="400"/>
-              </a:spcAft>
-              <a:defRPr sz="1200">
+              <a:t>•  Pre-GA Focus: Model tuning, trust/safety guardrails, telemetry integration.</a:t>
+            </a:r>
+          </a:p>
+          <a:p>
+            <a:pPr>
+              <a:spcBef>
+                <a:spcPts val="600"/>
+              </a:spcBef>
+              <a:defRPr sz="1250">
                 <a:solidFill>
                   <a:srgbClr val="172B4D"/>
                 </a:solidFill>
@@ -4456,53 +4320,21 @@
               </a:defRPr>
             </a:pPr>
             <a:r>
-              <a:t>•  Weekly retros — cut admin overhead</a:t>
-            </a:r>
-          </a:p>
-          <a:p>
-            <a:pPr>
-              <a:spcAft>
-                <a:spcPts val="400"/>
-              </a:spcAft>
-              <a:defRPr sz="1200">
-                <a:solidFill>
-                  <a:srgbClr val="172B4D"/>
-                </a:solidFill>
-                <a:latin typeface="Segoe UI"/>
-              </a:defRPr>
-            </a:pPr>
-            <a:r>
-              <a:t>•  Capture before/after evidence</a:t>
-            </a:r>
-          </a:p>
-          <a:p>
-            <a:pPr>
-              <a:spcAft>
-                <a:spcPts val="400"/>
-              </a:spcAft>
-              <a:defRPr sz="1200">
-                <a:solidFill>
-                  <a:srgbClr val="172B4D"/>
-                </a:solidFill>
-                <a:latin typeface="Segoe UI"/>
-              </a:defRPr>
-            </a:pPr>
-            <a:r>
-              <a:t>•  Activate PM champions</a:t>
-            </a:r>
-          </a:p>
-        </p:txBody>
-      </p:sp>
-      <p:sp>
-        <p:nvSpPr>
-          <p:cNvPr id="10" name="Rounded Rectangle 9"/>
+              <a:t>•  Cohort Gating: Widescale cohort feedback; benefits from frictionless Open Beta.</a:t>
+            </a:r>
+          </a:p>
+        </p:txBody>
+      </p:sp>
+      <p:sp>
+        <p:nvSpPr>
+          <p:cNvPr id="8" name="Rounded Rectangle 7"/>
           <p:cNvSpPr/>
           <p:nvPr/>
         </p:nvSpPr>
         <p:spPr>
           <a:xfrm>
-            <a:off x="4526280" y="5212080"/>
-            <a:ext cx="3108960" cy="640080"/>
+            <a:off x="731520" y="4754880"/>
+            <a:ext cx="10698480" cy="1280160"/>
           </a:xfrm>
           <a:prstGeom prst="roundRect">
             <a:avLst/>
@@ -4510,8 +4342,10 @@
           <a:solidFill>
             <a:srgbClr val="DEEBFF"/>
           </a:solidFill>
-          <a:ln>
-            <a:noFill/>
+          <a:ln w="12700">
+            <a:solidFill>
+              <a:srgbClr val="0052CC"/>
+            </a:solidFill>
           </a:ln>
         </p:spPr>
         <p:style>
@@ -4538,14 +4372,14 @@
       </p:sp>
       <p:sp>
         <p:nvSpPr>
-          <p:cNvPr id="11" name="TextBox 10"/>
+          <p:cNvPr id="9" name="TextBox 8"/>
           <p:cNvSpPr txBox="1"/>
           <p:nvPr/>
         </p:nvSpPr>
         <p:spPr>
           <a:xfrm>
-            <a:off x="4526280" y="5212080"/>
-            <a:ext cx="3108960" cy="640080"/>
+            <a:off x="914400" y="4846320"/>
+            <a:ext cx="10332720" cy="1097280"/>
           </a:xfrm>
           <a:prstGeom prst="rect">
             <a:avLst/>
@@ -4558,8 +4392,8 @@
           </a:bodyPr>
           <a:lstStyle/>
           <a:p>
-            <a:pPr algn="ctr">
-              <a:defRPr sz="1100" b="1">
+            <a:pPr>
+              <a:defRPr sz="1300" b="1">
                 <a:solidFill>
                   <a:srgbClr val="0052CC"/>
                 </a:solidFill>
@@ -4567,93 +4401,15 @@
               </a:defRPr>
             </a:pPr>
             <a:r>
-              <a:t>Playbook v1.0 + champion stories</a:t>
-            </a:r>
-          </a:p>
-        </p:txBody>
-      </p:sp>
-      <p:sp>
-        <p:nvSpPr>
-          <p:cNvPr id="12" name="Rounded Rectangle 11"/>
-          <p:cNvSpPr/>
-          <p:nvPr/>
-        </p:nvSpPr>
-        <p:spPr>
-          <a:xfrm>
-            <a:off x="8046720" y="1645920"/>
-            <a:ext cx="3383280" cy="4389120"/>
-          </a:xfrm>
-          <a:prstGeom prst="roundRect">
-            <a:avLst/>
-          </a:prstGeom>
-          <a:solidFill>
-            <a:srgbClr val="FFFFFF"/>
-          </a:solidFill>
-          <a:ln w="25400">
-            <a:solidFill>
-              <a:srgbClr val="36B37E"/>
-            </a:solidFill>
-          </a:ln>
-        </p:spPr>
-        <p:style>
-          <a:lnRef idx="1">
-            <a:schemeClr val="accent1"/>
-          </a:lnRef>
-          <a:fillRef idx="3">
-            <a:schemeClr val="accent1"/>
-          </a:fillRef>
-          <a:effectRef idx="2">
-            <a:schemeClr val="accent1"/>
-          </a:effectRef>
-          <a:fontRef idx="minor">
-            <a:schemeClr val="lt1"/>
-          </a:fontRef>
-        </p:style>
-        <p:txBody>
-          <a:bodyPr rtlCol="0" anchor="ctr"/>
-          <a:lstStyle/>
-          <a:p>
-            <a:pPr algn="ctr"/>
-          </a:p>
-        </p:txBody>
-      </p:sp>
-      <p:sp>
-        <p:nvSpPr>
-          <p:cNvPr id="13" name="TextBox 12"/>
-          <p:cNvSpPr txBox="1"/>
-          <p:nvPr/>
-        </p:nvSpPr>
-        <p:spPr>
-          <a:xfrm>
-            <a:off x="8183879" y="1737360"/>
-            <a:ext cx="3108960" cy="4206240"/>
-          </a:xfrm>
-          <a:prstGeom prst="rect">
-            <a:avLst/>
-          </a:prstGeom>
-          <a:noFill/>
-        </p:spPr>
-        <p:txBody>
-          <a:bodyPr wrap="square">
-            <a:spAutoFit/>
-          </a:bodyPr>
-          <a:lstStyle/>
-          <a:p>
-            <a:pPr>
-              <a:defRPr sz="1100" b="1">
-                <a:solidFill>
-                  <a:srgbClr val="36B37E"/>
-                </a:solidFill>
-                <a:latin typeface="Segoe UI"/>
-              </a:defRPr>
-            </a:pPr>
-            <a:r>
-              <a:t>PHASE 3</a:t>
-            </a:r>
-          </a:p>
-          <a:p>
-            <a:pPr>
-              <a:defRPr sz="1800" b="1">
+              <a:t>THE PRINCIPLE OF PROPORTIONAL GOVERNANCE</a:t>
+            </a:r>
+          </a:p>
+          <a:p>
+            <a:pPr>
+              <a:spcBef>
+                <a:spcPts val="400"/>
+              </a:spcBef>
+              <a:defRPr sz="1200">
                 <a:solidFill>
                   <a:srgbClr val="172B4D"/>
                 </a:solidFill>
@@ -4661,182 +4417,7 @@
               </a:defRPr>
             </a:pPr>
             <a:r>
-              <a:t>Days 61–90</a:t>
-            </a:r>
-          </a:p>
-          <a:p>
-            <a:pPr>
-              <a:spcAft>
-                <a:spcPts val="800"/>
-              </a:spcAft>
-              <a:defRPr sz="1300" i="1">
-                <a:solidFill>
-                  <a:srgbClr val="5E6C84"/>
-                </a:solidFill>
-                <a:latin typeface="Segoe UI"/>
-              </a:defRPr>
-            </a:pPr>
-            <a:r>
-              <a:t>Scale &amp; Institutionalise</a:t>
-            </a:r>
-          </a:p>
-          <a:p>
-            <a:pPr>
-              <a:spcAft>
-                <a:spcPts val="400"/>
-              </a:spcAft>
-              <a:defRPr sz="1200">
-                <a:solidFill>
-                  <a:srgbClr val="172B4D"/>
-                </a:solidFill>
-                <a:latin typeface="Segoe UI"/>
-              </a:defRPr>
-            </a:pPr>
-            <a:r>
-              <a:t>•  All-hands enablement session</a:t>
-            </a:r>
-          </a:p>
-          <a:p>
-            <a:pPr>
-              <a:spcAft>
-                <a:spcPts val="400"/>
-              </a:spcAft>
-              <a:defRPr sz="1200">
-                <a:solidFill>
-                  <a:srgbClr val="172B4D"/>
-                </a:solidFill>
-                <a:latin typeface="Segoe UI"/>
-              </a:defRPr>
-            </a:pPr>
-            <a:r>
-              <a:t>•  Self-serve KB + templates live</a:t>
-            </a:r>
-          </a:p>
-          <a:p>
-            <a:pPr>
-              <a:spcAft>
-                <a:spcPts val="400"/>
-              </a:spcAft>
-              <a:defRPr sz="1200">
-                <a:solidFill>
-                  <a:srgbClr val="172B4D"/>
-                </a:solidFill>
-                <a:latin typeface="Segoe UI"/>
-              </a:defRPr>
-            </a:pPr>
-            <a:r>
-              <a:t>•  #cucp-support + office hours</a:t>
-            </a:r>
-          </a:p>
-          <a:p>
-            <a:pPr>
-              <a:spcAft>
-                <a:spcPts val="400"/>
-              </a:spcAft>
-              <a:defRPr sz="1200">
-                <a:solidFill>
-                  <a:srgbClr val="172B4D"/>
-                </a:solidFill>
-                <a:latin typeface="Segoe UI"/>
-              </a:defRPr>
-            </a:pPr>
-            <a:r>
-              <a:t>•  Admin tasks automated</a:t>
-            </a:r>
-          </a:p>
-          <a:p>
-            <a:pPr>
-              <a:spcAft>
-                <a:spcPts val="400"/>
-              </a:spcAft>
-              <a:defRPr sz="1200">
-                <a:solidFill>
-                  <a:srgbClr val="172B4D"/>
-                </a:solidFill>
-                <a:latin typeface="Segoe UI"/>
-              </a:defRPr>
-            </a:pPr>
-            <a:r>
-              <a:t>•  Leadership dashboard live</a:t>
-            </a:r>
-          </a:p>
-        </p:txBody>
-      </p:sp>
-      <p:sp>
-        <p:nvSpPr>
-          <p:cNvPr id="14" name="Rounded Rectangle 13"/>
-          <p:cNvSpPr/>
-          <p:nvPr/>
-        </p:nvSpPr>
-        <p:spPr>
-          <a:xfrm>
-            <a:off x="8183879" y="5212080"/>
-            <a:ext cx="3108960" cy="640080"/>
-          </a:xfrm>
-          <a:prstGeom prst="roundRect">
-            <a:avLst/>
-          </a:prstGeom>
-          <a:solidFill>
-            <a:srgbClr val="36B37E"/>
-          </a:solidFill>
-          <a:ln>
-            <a:noFill/>
-          </a:ln>
-        </p:spPr>
-        <p:style>
-          <a:lnRef idx="1">
-            <a:schemeClr val="accent1"/>
-          </a:lnRef>
-          <a:fillRef idx="3">
-            <a:schemeClr val="accent1"/>
-          </a:fillRef>
-          <a:effectRef idx="2">
-            <a:schemeClr val="accent1"/>
-          </a:effectRef>
-          <a:fontRef idx="minor">
-            <a:schemeClr val="lt1"/>
-          </a:fontRef>
-        </p:style>
-        <p:txBody>
-          <a:bodyPr rtlCol="0" anchor="ctr"/>
-          <a:lstStyle/>
-          <a:p>
-            <a:pPr algn="ctr"/>
-          </a:p>
-        </p:txBody>
-      </p:sp>
-      <p:sp>
-        <p:nvSpPr>
-          <p:cNvPr id="15" name="TextBox 14"/>
-          <p:cNvSpPr txBox="1"/>
-          <p:nvPr/>
-        </p:nvSpPr>
-        <p:spPr>
-          <a:xfrm>
-            <a:off x="8183879" y="5212080"/>
-            <a:ext cx="3108960" cy="640080"/>
-          </a:xfrm>
-          <a:prstGeom prst="rect">
-            <a:avLst/>
-          </a:prstGeom>
-          <a:noFill/>
-        </p:spPr>
-        <p:txBody>
-          <a:bodyPr wrap="square">
-            <a:spAutoFit/>
-          </a:bodyPr>
-          <a:lstStyle/>
-          <a:p>
-            <a:pPr algn="ctr">
-              <a:defRPr sz="1100" b="1">
-                <a:solidFill>
-                  <a:srgbClr val="FFFFFF"/>
-                </a:solidFill>
-                <a:latin typeface="Segoe UI"/>
-              </a:defRPr>
-            </a:pPr>
-            <a:r>
-              <a:t>All PMs enabled · tracking live</a:t>
+              <a:t>The level of release gating must align to feature risk, complexity, and operational impact. Pre-GA (LA &amp; Open Beta) phases are optional and variable. The PM determines if Phase 2 is required based on features.</a:t>
             </a:r>
           </a:p>
         </p:txBody>
@@ -4898,6 +4479,911 @@
               </a:defRPr>
             </a:pPr>
             <a:r>
+              <a:t>90-Day Rollout Execution: Pilot → Learn → Scale</a:t>
+            </a:r>
+          </a:p>
+        </p:txBody>
+      </p:sp>
+      <p:sp>
+        <p:nvSpPr>
+          <p:cNvPr id="3" name="TextBox 2"/>
+          <p:cNvSpPr txBox="1"/>
+          <p:nvPr/>
+        </p:nvSpPr>
+        <p:spPr>
+          <a:xfrm>
+            <a:off x="731520" y="1005840"/>
+            <a:ext cx="10698480" cy="365760"/>
+          </a:xfrm>
+          <a:prstGeom prst="rect">
+            <a:avLst/>
+          </a:prstGeom>
+          <a:noFill/>
+        </p:spPr>
+        <p:txBody>
+          <a:bodyPr wrap="square">
+            <a:spAutoFit/>
+          </a:bodyPr>
+          <a:lstStyle/>
+          <a:p>
+            <a:pPr>
+              <a:defRPr sz="1300">
+                <a:solidFill>
+                  <a:srgbClr val="5E6C84"/>
+                </a:solidFill>
+                <a:latin typeface="Segoe UI"/>
+              </a:defRPr>
+            </a:pPr>
+            <a:r>
+              <a:t>No big-bang mandate. Build trust through service, then scale on proven evidence.</a:t>
+            </a:r>
+          </a:p>
+        </p:txBody>
+      </p:sp>
+      <p:sp>
+        <p:nvSpPr>
+          <p:cNvPr id="4" name="Rounded Rectangle 3"/>
+          <p:cNvSpPr/>
+          <p:nvPr/>
+        </p:nvSpPr>
+        <p:spPr>
+          <a:xfrm>
+            <a:off x="731520" y="1645920"/>
+            <a:ext cx="3383280" cy="4389120"/>
+          </a:xfrm>
+          <a:prstGeom prst="roundRect">
+            <a:avLst/>
+          </a:prstGeom>
+          <a:solidFill>
+            <a:srgbClr val="FFFFFF"/>
+          </a:solidFill>
+          <a:ln w="25400">
+            <a:solidFill>
+              <a:srgbClr val="FFAB00"/>
+            </a:solidFill>
+          </a:ln>
+        </p:spPr>
+        <p:style>
+          <a:lnRef idx="1">
+            <a:schemeClr val="accent1"/>
+          </a:lnRef>
+          <a:fillRef idx="3">
+            <a:schemeClr val="accent1"/>
+          </a:fillRef>
+          <a:effectRef idx="2">
+            <a:schemeClr val="accent1"/>
+          </a:effectRef>
+          <a:fontRef idx="minor">
+            <a:schemeClr val="lt1"/>
+          </a:fontRef>
+        </p:style>
+        <p:txBody>
+          <a:bodyPr rtlCol="0" anchor="ctr"/>
+          <a:lstStyle/>
+          <a:p>
+            <a:pPr algn="ctr"/>
+          </a:p>
+        </p:txBody>
+      </p:sp>
+      <p:sp>
+        <p:nvSpPr>
+          <p:cNvPr id="5" name="TextBox 4"/>
+          <p:cNvSpPr txBox="1"/>
+          <p:nvPr/>
+        </p:nvSpPr>
+        <p:spPr>
+          <a:xfrm>
+            <a:off x="868680" y="1737360"/>
+            <a:ext cx="3108960" cy="4206240"/>
+          </a:xfrm>
+          <a:prstGeom prst="rect">
+            <a:avLst/>
+          </a:prstGeom>
+          <a:noFill/>
+        </p:spPr>
+        <p:txBody>
+          <a:bodyPr wrap="square">
+            <a:spAutoFit/>
+          </a:bodyPr>
+          <a:lstStyle/>
+          <a:p>
+            <a:pPr>
+              <a:defRPr sz="1100" b="1">
+                <a:solidFill>
+                  <a:srgbClr val="FFAB00"/>
+                </a:solidFill>
+                <a:latin typeface="Segoe UI"/>
+              </a:defRPr>
+            </a:pPr>
+            <a:r>
+              <a:t>PHASE 1</a:t>
+            </a:r>
+          </a:p>
+          <a:p>
+            <a:pPr>
+              <a:defRPr sz="1800" b="1">
+                <a:solidFill>
+                  <a:srgbClr val="172B4D"/>
+                </a:solidFill>
+                <a:latin typeface="Segoe UI"/>
+              </a:defRPr>
+            </a:pPr>
+            <a:r>
+              <a:t>Days 1–30</a:t>
+            </a:r>
+          </a:p>
+          <a:p>
+            <a:pPr>
+              <a:spcAft>
+                <a:spcPts val="800"/>
+              </a:spcAft>
+              <a:defRPr sz="1300" i="1">
+                <a:solidFill>
+                  <a:srgbClr val="5E6C84"/>
+                </a:solidFill>
+                <a:latin typeface="Segoe UI"/>
+              </a:defRPr>
+            </a:pPr>
+            <a:r>
+              <a:t>Listen &amp; Align</a:t>
+            </a:r>
+          </a:p>
+          <a:p>
+            <a:pPr>
+              <a:spcAft>
+                <a:spcPts val="400"/>
+              </a:spcAft>
+              <a:defRPr sz="1200">
+                <a:solidFill>
+                  <a:srgbClr val="172B4D"/>
+                </a:solidFill>
+                <a:latin typeface="Segoe UI"/>
+              </a:defRPr>
+            </a:pPr>
+            <a:r>
+              <a:t>•  1:1 listening sessions (8–10 PMs)</a:t>
+            </a:r>
+          </a:p>
+          <a:p>
+            <a:pPr>
+              <a:spcAft>
+                <a:spcPts val="400"/>
+              </a:spcAft>
+              <a:defRPr sz="1200">
+                <a:solidFill>
+                  <a:srgbClr val="172B4D"/>
+                </a:solidFill>
+                <a:latin typeface="Segoe UI"/>
+              </a:defRPr>
+            </a:pPr>
+            <a:r>
+              <a:t>•  Shadow EAP/LA release cycles</a:t>
+            </a:r>
+          </a:p>
+          <a:p>
+            <a:pPr>
+              <a:spcAft>
+                <a:spcPts val="400"/>
+              </a:spcAft>
+              <a:defRPr sz="1200">
+                <a:solidFill>
+                  <a:srgbClr val="172B4D"/>
+                </a:solidFill>
+                <a:latin typeface="Segoe UI"/>
+              </a:defRPr>
+            </a:pPr>
+            <a:r>
+              <a:t>•  Map informal processes in use</a:t>
+            </a:r>
+          </a:p>
+          <a:p>
+            <a:pPr>
+              <a:spcAft>
+                <a:spcPts val="400"/>
+              </a:spcAft>
+              <a:defRPr sz="1200">
+                <a:solidFill>
+                  <a:srgbClr val="172B4D"/>
+                </a:solidFill>
+                <a:latin typeface="Segoe UI"/>
+              </a:defRPr>
+            </a:pPr>
+            <a:r>
+              <a:t>•  Identify proto-champions</a:t>
+            </a:r>
+          </a:p>
+          <a:p>
+            <a:pPr>
+              <a:spcAft>
+                <a:spcPts val="400"/>
+              </a:spcAft>
+              <a:defRPr sz="1200">
+                <a:solidFill>
+                  <a:srgbClr val="172B4D"/>
+                </a:solidFill>
+                <a:latin typeface="Segoe UI"/>
+              </a:defRPr>
+            </a:pPr>
+            <a:r>
+              <a:t>•  Select pilots: 1 Std + 1 AI release</a:t>
+            </a:r>
+          </a:p>
+        </p:txBody>
+      </p:sp>
+      <p:sp>
+        <p:nvSpPr>
+          <p:cNvPr id="6" name="Rounded Rectangle 5"/>
+          <p:cNvSpPr/>
+          <p:nvPr/>
+        </p:nvSpPr>
+        <p:spPr>
+          <a:xfrm>
+            <a:off x="868680" y="5212080"/>
+            <a:ext cx="3108960" cy="640080"/>
+          </a:xfrm>
+          <a:prstGeom prst="roundRect">
+            <a:avLst/>
+          </a:prstGeom>
+          <a:solidFill>
+            <a:srgbClr val="FFF0B5"/>
+          </a:solidFill>
+          <a:ln>
+            <a:noFill/>
+          </a:ln>
+        </p:spPr>
+        <p:style>
+          <a:lnRef idx="1">
+            <a:schemeClr val="accent1"/>
+          </a:lnRef>
+          <a:fillRef idx="3">
+            <a:schemeClr val="accent1"/>
+          </a:fillRef>
+          <a:effectRef idx="2">
+            <a:schemeClr val="accent1"/>
+          </a:effectRef>
+          <a:fontRef idx="minor">
+            <a:schemeClr val="lt1"/>
+          </a:fontRef>
+        </p:style>
+        <p:txBody>
+          <a:bodyPr rtlCol="0" anchor="ctr"/>
+          <a:lstStyle/>
+          <a:p>
+            <a:pPr algn="ctr"/>
+          </a:p>
+        </p:txBody>
+      </p:sp>
+      <p:sp>
+        <p:nvSpPr>
+          <p:cNvPr id="7" name="TextBox 6"/>
+          <p:cNvSpPr txBox="1"/>
+          <p:nvPr/>
+        </p:nvSpPr>
+        <p:spPr>
+          <a:xfrm>
+            <a:off x="868680" y="5212080"/>
+            <a:ext cx="3108960" cy="640080"/>
+          </a:xfrm>
+          <a:prstGeom prst="rect">
+            <a:avLst/>
+          </a:prstGeom>
+          <a:noFill/>
+        </p:spPr>
+        <p:txBody>
+          <a:bodyPr wrap="square">
+            <a:spAutoFit/>
+          </a:bodyPr>
+          <a:lstStyle/>
+          <a:p>
+            <a:pPr algn="ctr">
+              <a:defRPr sz="1100" b="1">
+                <a:solidFill>
+                  <a:srgbClr val="172B4D"/>
+                </a:solidFill>
+                <a:latin typeface="Segoe UI"/>
+              </a:defRPr>
+            </a:pPr>
+            <a:r>
+              <a:t>Friction map + pilot cohort confirmed</a:t>
+            </a:r>
+          </a:p>
+        </p:txBody>
+      </p:sp>
+      <p:sp>
+        <p:nvSpPr>
+          <p:cNvPr id="8" name="Rounded Rectangle 7"/>
+          <p:cNvSpPr/>
+          <p:nvPr/>
+        </p:nvSpPr>
+        <p:spPr>
+          <a:xfrm>
+            <a:off x="4389120" y="1645920"/>
+            <a:ext cx="3383280" cy="4389120"/>
+          </a:xfrm>
+          <a:prstGeom prst="roundRect">
+            <a:avLst/>
+          </a:prstGeom>
+          <a:solidFill>
+            <a:srgbClr val="FFFFFF"/>
+          </a:solidFill>
+          <a:ln w="25400">
+            <a:solidFill>
+              <a:srgbClr val="0052CC"/>
+            </a:solidFill>
+          </a:ln>
+        </p:spPr>
+        <p:style>
+          <a:lnRef idx="1">
+            <a:schemeClr val="accent1"/>
+          </a:lnRef>
+          <a:fillRef idx="3">
+            <a:schemeClr val="accent1"/>
+          </a:fillRef>
+          <a:effectRef idx="2">
+            <a:schemeClr val="accent1"/>
+          </a:effectRef>
+          <a:fontRef idx="minor">
+            <a:schemeClr val="lt1"/>
+          </a:fontRef>
+        </p:style>
+        <p:txBody>
+          <a:bodyPr rtlCol="0" anchor="ctr"/>
+          <a:lstStyle/>
+          <a:p>
+            <a:pPr algn="ctr"/>
+          </a:p>
+        </p:txBody>
+      </p:sp>
+      <p:sp>
+        <p:nvSpPr>
+          <p:cNvPr id="9" name="TextBox 8"/>
+          <p:cNvSpPr txBox="1"/>
+          <p:nvPr/>
+        </p:nvSpPr>
+        <p:spPr>
+          <a:xfrm>
+            <a:off x="4526280" y="1737360"/>
+            <a:ext cx="3108960" cy="4206240"/>
+          </a:xfrm>
+          <a:prstGeom prst="rect">
+            <a:avLst/>
+          </a:prstGeom>
+          <a:noFill/>
+        </p:spPr>
+        <p:txBody>
+          <a:bodyPr wrap="square">
+            <a:spAutoFit/>
+          </a:bodyPr>
+          <a:lstStyle/>
+          <a:p>
+            <a:pPr>
+              <a:defRPr sz="1100" b="1">
+                <a:solidFill>
+                  <a:srgbClr val="0052CC"/>
+                </a:solidFill>
+                <a:latin typeface="Segoe UI"/>
+              </a:defRPr>
+            </a:pPr>
+            <a:r>
+              <a:t>PHASE 2</a:t>
+            </a:r>
+          </a:p>
+          <a:p>
+            <a:pPr>
+              <a:defRPr sz="1800" b="1">
+                <a:solidFill>
+                  <a:srgbClr val="172B4D"/>
+                </a:solidFill>
+                <a:latin typeface="Segoe UI"/>
+              </a:defRPr>
+            </a:pPr>
+            <a:r>
+              <a:t>Days 31–60</a:t>
+            </a:r>
+          </a:p>
+          <a:p>
+            <a:pPr>
+              <a:spcAft>
+                <a:spcPts val="800"/>
+              </a:spcAft>
+              <a:defRPr sz="1300" i="1">
+                <a:solidFill>
+                  <a:srgbClr val="5E6C84"/>
+                </a:solidFill>
+                <a:latin typeface="Segoe UI"/>
+              </a:defRPr>
+            </a:pPr>
+            <a:r>
+              <a:t>Pilot &amp; Refine</a:t>
+            </a:r>
+          </a:p>
+          <a:p>
+            <a:pPr>
+              <a:spcAft>
+                <a:spcPts val="400"/>
+              </a:spcAft>
+              <a:defRPr sz="1200">
+                <a:solidFill>
+                  <a:srgbClr val="172B4D"/>
+                </a:solidFill>
+                <a:latin typeface="Segoe UI"/>
+              </a:defRPr>
+            </a:pPr>
+            <a:r>
+              <a:t>•  Run 2–3 live CuCP pilots</a:t>
+            </a:r>
+          </a:p>
+          <a:p>
+            <a:pPr>
+              <a:spcAft>
+                <a:spcPts val="400"/>
+              </a:spcAft>
+              <a:defRPr sz="1200">
+                <a:solidFill>
+                  <a:srgbClr val="172B4D"/>
+                </a:solidFill>
+                <a:latin typeface="Segoe UI"/>
+              </a:defRPr>
+            </a:pPr>
+            <a:r>
+              <a:t>•  I act as embedded CuCP Concierge</a:t>
+            </a:r>
+          </a:p>
+          <a:p>
+            <a:pPr>
+              <a:spcAft>
+                <a:spcPts val="400"/>
+              </a:spcAft>
+              <a:defRPr sz="1200">
+                <a:solidFill>
+                  <a:srgbClr val="172B4D"/>
+                </a:solidFill>
+                <a:latin typeface="Segoe UI"/>
+              </a:defRPr>
+            </a:pPr>
+            <a:r>
+              <a:t>•  Weekly retros — cut admin overhead</a:t>
+            </a:r>
+          </a:p>
+          <a:p>
+            <a:pPr>
+              <a:spcAft>
+                <a:spcPts val="400"/>
+              </a:spcAft>
+              <a:defRPr sz="1200">
+                <a:solidFill>
+                  <a:srgbClr val="172B4D"/>
+                </a:solidFill>
+                <a:latin typeface="Segoe UI"/>
+              </a:defRPr>
+            </a:pPr>
+            <a:r>
+              <a:t>•  Capture before/after evidence</a:t>
+            </a:r>
+          </a:p>
+          <a:p>
+            <a:pPr>
+              <a:spcAft>
+                <a:spcPts val="400"/>
+              </a:spcAft>
+              <a:defRPr sz="1200">
+                <a:solidFill>
+                  <a:srgbClr val="172B4D"/>
+                </a:solidFill>
+                <a:latin typeface="Segoe UI"/>
+              </a:defRPr>
+            </a:pPr>
+            <a:r>
+              <a:t>•  Activate PM champions</a:t>
+            </a:r>
+          </a:p>
+        </p:txBody>
+      </p:sp>
+      <p:sp>
+        <p:nvSpPr>
+          <p:cNvPr id="10" name="Rounded Rectangle 9"/>
+          <p:cNvSpPr/>
+          <p:nvPr/>
+        </p:nvSpPr>
+        <p:spPr>
+          <a:xfrm>
+            <a:off x="4526280" y="5212080"/>
+            <a:ext cx="3108960" cy="640080"/>
+          </a:xfrm>
+          <a:prstGeom prst="roundRect">
+            <a:avLst/>
+          </a:prstGeom>
+          <a:solidFill>
+            <a:srgbClr val="DEEBFF"/>
+          </a:solidFill>
+          <a:ln>
+            <a:noFill/>
+          </a:ln>
+        </p:spPr>
+        <p:style>
+          <a:lnRef idx="1">
+            <a:schemeClr val="accent1"/>
+          </a:lnRef>
+          <a:fillRef idx="3">
+            <a:schemeClr val="accent1"/>
+          </a:fillRef>
+          <a:effectRef idx="2">
+            <a:schemeClr val="accent1"/>
+          </a:effectRef>
+          <a:fontRef idx="minor">
+            <a:schemeClr val="lt1"/>
+          </a:fontRef>
+        </p:style>
+        <p:txBody>
+          <a:bodyPr rtlCol="0" anchor="ctr"/>
+          <a:lstStyle/>
+          <a:p>
+            <a:pPr algn="ctr"/>
+          </a:p>
+        </p:txBody>
+      </p:sp>
+      <p:sp>
+        <p:nvSpPr>
+          <p:cNvPr id="11" name="TextBox 10"/>
+          <p:cNvSpPr txBox="1"/>
+          <p:nvPr/>
+        </p:nvSpPr>
+        <p:spPr>
+          <a:xfrm>
+            <a:off x="4526280" y="5212080"/>
+            <a:ext cx="3108960" cy="640080"/>
+          </a:xfrm>
+          <a:prstGeom prst="rect">
+            <a:avLst/>
+          </a:prstGeom>
+          <a:noFill/>
+        </p:spPr>
+        <p:txBody>
+          <a:bodyPr wrap="square">
+            <a:spAutoFit/>
+          </a:bodyPr>
+          <a:lstStyle/>
+          <a:p>
+            <a:pPr algn="ctr">
+              <a:defRPr sz="1100" b="1">
+                <a:solidFill>
+                  <a:srgbClr val="0052CC"/>
+                </a:solidFill>
+                <a:latin typeface="Segoe UI"/>
+              </a:defRPr>
+            </a:pPr>
+            <a:r>
+              <a:t>Playbook v1.0 + champion stories</a:t>
+            </a:r>
+          </a:p>
+        </p:txBody>
+      </p:sp>
+      <p:sp>
+        <p:nvSpPr>
+          <p:cNvPr id="12" name="Rounded Rectangle 11"/>
+          <p:cNvSpPr/>
+          <p:nvPr/>
+        </p:nvSpPr>
+        <p:spPr>
+          <a:xfrm>
+            <a:off x="8046720" y="1645920"/>
+            <a:ext cx="3383280" cy="4389120"/>
+          </a:xfrm>
+          <a:prstGeom prst="roundRect">
+            <a:avLst/>
+          </a:prstGeom>
+          <a:solidFill>
+            <a:srgbClr val="FFFFFF"/>
+          </a:solidFill>
+          <a:ln w="25400">
+            <a:solidFill>
+              <a:srgbClr val="36B37E"/>
+            </a:solidFill>
+          </a:ln>
+        </p:spPr>
+        <p:style>
+          <a:lnRef idx="1">
+            <a:schemeClr val="accent1"/>
+          </a:lnRef>
+          <a:fillRef idx="3">
+            <a:schemeClr val="accent1"/>
+          </a:fillRef>
+          <a:effectRef idx="2">
+            <a:schemeClr val="accent1"/>
+          </a:effectRef>
+          <a:fontRef idx="minor">
+            <a:schemeClr val="lt1"/>
+          </a:fontRef>
+        </p:style>
+        <p:txBody>
+          <a:bodyPr rtlCol="0" anchor="ctr"/>
+          <a:lstStyle/>
+          <a:p>
+            <a:pPr algn="ctr"/>
+          </a:p>
+        </p:txBody>
+      </p:sp>
+      <p:sp>
+        <p:nvSpPr>
+          <p:cNvPr id="13" name="TextBox 12"/>
+          <p:cNvSpPr txBox="1"/>
+          <p:nvPr/>
+        </p:nvSpPr>
+        <p:spPr>
+          <a:xfrm>
+            <a:off x="8183879" y="1737360"/>
+            <a:ext cx="3108960" cy="4206240"/>
+          </a:xfrm>
+          <a:prstGeom prst="rect">
+            <a:avLst/>
+          </a:prstGeom>
+          <a:noFill/>
+        </p:spPr>
+        <p:txBody>
+          <a:bodyPr wrap="square">
+            <a:spAutoFit/>
+          </a:bodyPr>
+          <a:lstStyle/>
+          <a:p>
+            <a:pPr>
+              <a:defRPr sz="1100" b="1">
+                <a:solidFill>
+                  <a:srgbClr val="36B37E"/>
+                </a:solidFill>
+                <a:latin typeface="Segoe UI"/>
+              </a:defRPr>
+            </a:pPr>
+            <a:r>
+              <a:t>PHASE 3</a:t>
+            </a:r>
+          </a:p>
+          <a:p>
+            <a:pPr>
+              <a:defRPr sz="1800" b="1">
+                <a:solidFill>
+                  <a:srgbClr val="172B4D"/>
+                </a:solidFill>
+                <a:latin typeface="Segoe UI"/>
+              </a:defRPr>
+            </a:pPr>
+            <a:r>
+              <a:t>Days 61–90</a:t>
+            </a:r>
+          </a:p>
+          <a:p>
+            <a:pPr>
+              <a:spcAft>
+                <a:spcPts val="800"/>
+              </a:spcAft>
+              <a:defRPr sz="1300" i="1">
+                <a:solidFill>
+                  <a:srgbClr val="5E6C84"/>
+                </a:solidFill>
+                <a:latin typeface="Segoe UI"/>
+              </a:defRPr>
+            </a:pPr>
+            <a:r>
+              <a:t>Scale &amp; Institutionalise</a:t>
+            </a:r>
+          </a:p>
+          <a:p>
+            <a:pPr>
+              <a:spcAft>
+                <a:spcPts val="400"/>
+              </a:spcAft>
+              <a:defRPr sz="1200">
+                <a:solidFill>
+                  <a:srgbClr val="172B4D"/>
+                </a:solidFill>
+                <a:latin typeface="Segoe UI"/>
+              </a:defRPr>
+            </a:pPr>
+            <a:r>
+              <a:t>•  All-hands enablement session</a:t>
+            </a:r>
+          </a:p>
+          <a:p>
+            <a:pPr>
+              <a:spcAft>
+                <a:spcPts val="400"/>
+              </a:spcAft>
+              <a:defRPr sz="1200">
+                <a:solidFill>
+                  <a:srgbClr val="172B4D"/>
+                </a:solidFill>
+                <a:latin typeface="Segoe UI"/>
+              </a:defRPr>
+            </a:pPr>
+            <a:r>
+              <a:t>•  Self-serve KB + templates live</a:t>
+            </a:r>
+          </a:p>
+          <a:p>
+            <a:pPr>
+              <a:spcAft>
+                <a:spcPts val="400"/>
+              </a:spcAft>
+              <a:defRPr sz="1200">
+                <a:solidFill>
+                  <a:srgbClr val="172B4D"/>
+                </a:solidFill>
+                <a:latin typeface="Segoe UI"/>
+              </a:defRPr>
+            </a:pPr>
+            <a:r>
+              <a:t>•  #cucp-support + office hours</a:t>
+            </a:r>
+          </a:p>
+          <a:p>
+            <a:pPr>
+              <a:spcAft>
+                <a:spcPts val="400"/>
+              </a:spcAft>
+              <a:defRPr sz="1200">
+                <a:solidFill>
+                  <a:srgbClr val="172B4D"/>
+                </a:solidFill>
+                <a:latin typeface="Segoe UI"/>
+              </a:defRPr>
+            </a:pPr>
+            <a:r>
+              <a:t>•  Admin tasks automated</a:t>
+            </a:r>
+          </a:p>
+          <a:p>
+            <a:pPr>
+              <a:spcAft>
+                <a:spcPts val="400"/>
+              </a:spcAft>
+              <a:defRPr sz="1200">
+                <a:solidFill>
+                  <a:srgbClr val="172B4D"/>
+                </a:solidFill>
+                <a:latin typeface="Segoe UI"/>
+              </a:defRPr>
+            </a:pPr>
+            <a:r>
+              <a:t>•  Leadership dashboard live</a:t>
+            </a:r>
+          </a:p>
+        </p:txBody>
+      </p:sp>
+      <p:sp>
+        <p:nvSpPr>
+          <p:cNvPr id="14" name="Rounded Rectangle 13"/>
+          <p:cNvSpPr/>
+          <p:nvPr/>
+        </p:nvSpPr>
+        <p:spPr>
+          <a:xfrm>
+            <a:off x="8183879" y="5212080"/>
+            <a:ext cx="3108960" cy="640080"/>
+          </a:xfrm>
+          <a:prstGeom prst="roundRect">
+            <a:avLst/>
+          </a:prstGeom>
+          <a:solidFill>
+            <a:srgbClr val="36B37E"/>
+          </a:solidFill>
+          <a:ln>
+            <a:noFill/>
+          </a:ln>
+        </p:spPr>
+        <p:style>
+          <a:lnRef idx="1">
+            <a:schemeClr val="accent1"/>
+          </a:lnRef>
+          <a:fillRef idx="3">
+            <a:schemeClr val="accent1"/>
+          </a:fillRef>
+          <a:effectRef idx="2">
+            <a:schemeClr val="accent1"/>
+          </a:effectRef>
+          <a:fontRef idx="minor">
+            <a:schemeClr val="lt1"/>
+          </a:fontRef>
+        </p:style>
+        <p:txBody>
+          <a:bodyPr rtlCol="0" anchor="ctr"/>
+          <a:lstStyle/>
+          <a:p>
+            <a:pPr algn="ctr"/>
+          </a:p>
+        </p:txBody>
+      </p:sp>
+      <p:sp>
+        <p:nvSpPr>
+          <p:cNvPr id="15" name="TextBox 14"/>
+          <p:cNvSpPr txBox="1"/>
+          <p:nvPr/>
+        </p:nvSpPr>
+        <p:spPr>
+          <a:xfrm>
+            <a:off x="8183879" y="5212080"/>
+            <a:ext cx="3108960" cy="640080"/>
+          </a:xfrm>
+          <a:prstGeom prst="rect">
+            <a:avLst/>
+          </a:prstGeom>
+          <a:noFill/>
+        </p:spPr>
+        <p:txBody>
+          <a:bodyPr wrap="square">
+            <a:spAutoFit/>
+          </a:bodyPr>
+          <a:lstStyle/>
+          <a:p>
+            <a:pPr algn="ctr">
+              <a:defRPr sz="1100" b="1">
+                <a:solidFill>
+                  <a:srgbClr val="FFFFFF"/>
+                </a:solidFill>
+                <a:latin typeface="Segoe UI"/>
+              </a:defRPr>
+            </a:pPr>
+            <a:r>
+              <a:t>All PMs enabled · tracking live</a:t>
+            </a:r>
+          </a:p>
+        </p:txBody>
+      </p:sp>
+    </p:spTree>
+  </p:cSld>
+  <p:clrMapOvr>
+    <a:masterClrMapping/>
+  </p:clrMapOvr>
+</p:sld>
+</file>
+
+<file path=ppt/slides/slide5.xml><?xml version="1.0" encoding="utf-8"?>
+<p:sld xmlns:a="http://schemas.openxmlformats.org/drawingml/2006/main" xmlns:p="http://schemas.openxmlformats.org/presentationml/2006/main" xmlns:r="http://schemas.openxmlformats.org/officeDocument/2006/relationships">
+  <p:cSld>
+    <p:bg>
+      <p:bgPr>
+        <a:solidFill>
+          <a:srgbClr val="F8FAFC"/>
+        </a:solidFill>
+        <a:effectLst/>
+      </p:bgPr>
+    </p:bg>
+    <p:spTree>
+      <p:nvGrpSpPr>
+        <p:cNvPr id="1" name=""/>
+        <p:cNvGrpSpPr/>
+        <p:nvPr/>
+      </p:nvGrpSpPr>
+      <p:grpSpPr/>
+      <p:sp>
+        <p:nvSpPr>
+          <p:cNvPr id="2" name="TextBox 1"/>
+          <p:cNvSpPr txBox="1"/>
+          <p:nvPr/>
+        </p:nvSpPr>
+        <p:spPr>
+          <a:xfrm>
+            <a:off x="731520" y="457200"/>
+            <a:ext cx="10698480" cy="640080"/>
+          </a:xfrm>
+          <a:prstGeom prst="rect">
+            <a:avLst/>
+          </a:prstGeom>
+          <a:noFill/>
+        </p:spPr>
+        <p:txBody>
+          <a:bodyPr wrap="square">
+            <a:spAutoFit/>
+          </a:bodyPr>
+          <a:lstStyle/>
+          <a:p>
+            <a:pPr>
+              <a:defRPr sz="2600" b="1">
+                <a:solidFill>
+                  <a:srgbClr val="172B4D"/>
+                </a:solidFill>
+                <a:latin typeface="Segoe UI"/>
+              </a:defRPr>
+            </a:pPr>
+            <a:r>
               <a:t>Enablement &amp; Support Model</a:t>
             </a:r>
           </a:p>
@@ -5651,7 +6137,7 @@
 </p:sld>
 </file>
 
-<file path=ppt/slides/slide5.xml><?xml version="1.0" encoding="utf-8"?>
+<file path=ppt/slides/slide6.xml><?xml version="1.0" encoding="utf-8"?>
 <p:sld xmlns:a="http://schemas.openxmlformats.org/drawingml/2006/main" xmlns:p="http://schemas.openxmlformats.org/presentationml/2006/main" xmlns:r="http://schemas.openxmlformats.org/officeDocument/2006/relationships">
   <p:cSld>
     <p:bg>
@@ -6668,7 +7154,7 @@
 </p:sld>
 </file>
 
-<file path=ppt/slides/slide6.xml><?xml version="1.0" encoding="utf-8"?>
+<file path=ppt/slides/slide7.xml><?xml version="1.0" encoding="utf-8"?>
 <p:sld xmlns:a="http://schemas.openxmlformats.org/drawingml/2006/main" xmlns:p="http://schemas.openxmlformats.org/presentationml/2006/main" xmlns:r="http://schemas.openxmlformats.org/officeDocument/2006/relationships">
   <p:cSld>
     <p:bg>

</xml_diff>

<commit_message>
Refine Slide 3 Capability Classifications in HTML and PPTX slide decks to match Coupa CuCP matrix details
</commit_message>
<xml_diff>
--- a/docs/cucp/cucp_presentation.pptx
+++ b/docs/cucp/cucp_presentation.pptx
@@ -4127,7 +4127,7 @@
               </a:defRPr>
             </a:pPr>
             <a:r>
-              <a:t>•  Definition: Built on deterministic logic and structured workflows (no AI).</a:t>
+              <a:t>•  Definition: Deterministic logic and workflows (no AI involved). E.g., dashboards, routing rules.</a:t>
             </a:r>
           </a:p>
           <a:p>
@@ -4143,7 +4143,7 @@
               </a:defRPr>
             </a:pPr>
             <a:r>
-              <a:t>•  Examples: New sourcing dashboards, workflow routing rules, UI redesigns.</a:t>
+              <a:t>•  Focus: Validate operational readiness, scalability, support enablement.</a:t>
             </a:r>
           </a:p>
           <a:p>
@@ -4159,7 +4159,7 @@
               </a:defRPr>
             </a:pPr>
             <a:r>
-              <a:t>•  Pre-GA Focus: Validate operational readiness, scalability, support enablement.</a:t>
+              <a:t>•  Gating: Closed Beta (EAP) and Limited Availability (LA) require a $0 Order Form.</a:t>
             </a:r>
           </a:p>
           <a:p>
@@ -4175,7 +4175,7 @@
               </a:defRPr>
             </a:pPr>
             <a:r>
-              <a:t>•  Cohort Sizes: Controlled, small customer cohorts (5-10 max) are sufficient.</a:t>
+              <a:t>•  Exit: LA phase gates readiness with commercial alignment before General Availability.</a:t>
             </a:r>
           </a:p>
         </p:txBody>
@@ -4272,7 +4272,7 @@
               </a:defRPr>
             </a:pPr>
             <a:r>
-              <a:t>•  Definition: Powered by ML/LLMs. Probabilistic models requiring user feedback loop.</a:t>
+              <a:t>•  Definition: Powered by ML/LLMs. Probabilistic models. E.g., Copilots, Agent Studio.</a:t>
             </a:r>
           </a:p>
           <a:p>
@@ -4288,7 +4288,7 @@
               </a:defRPr>
             </a:pPr>
             <a:r>
-              <a:t>•  Examples: Copilot context recommendations, Agent Studio autonomous workflows.</a:t>
+              <a:t>•  Focus: Model tuning, trust/safety guardrails, telemetry integration.</a:t>
             </a:r>
           </a:p>
           <a:p>
@@ -4304,7 +4304,7 @@
               </a:defRPr>
             </a:pPr>
             <a:r>
-              <a:t>•  Pre-GA Focus: Model tuning, trust/safety guardrails, telemetry integration.</a:t>
+              <a:t>•  Billing: EAP &amp; Open Beta are free of charge via customer AI Credits.</a:t>
             </a:r>
           </a:p>
           <a:p>
@@ -4320,7 +4320,7 @@
               </a:defRPr>
             </a:pPr>
             <a:r>
-              <a:t>•  Cohort Gating: Widescale cohort feedback; benefits from frictionless Open Beta.</a:t>
+              <a:t>•  Gating: Open Beta is enabled via UI toggle (no $0 Order Forms; utilizes Fair Use Caps).</a:t>
             </a:r>
           </a:p>
         </p:txBody>

</xml_diff>